<commit_message>
docs: credit Stanford OVAL (STORM/Co-STORM) explicitly in the pitch
Reforca a credencial academica por tras da tecnica multi-perspectiva:
citacao completa de Shao et al. (STORM, NAACL 2024) em research.md R2,
com escopo explicito do que foi adaptado vs. nao implementado (para
nao superestimar na arguicao). Co-STORM (Jiang et al., EMNLP 2024)
registrado como evolucao futura genuina em critical-review.md, nao
como funcionalidade existente.

arguicao.md ganha resposta proativa citando as referencias + uma nova
pergunta dedicada distinguindo STORM de Co-STORM. Slide 7 do deck
ganha citacao visivel (Shao et al., Stanford OVAL) com verificacao
visual de que nao colide com o conteudo existente.

Co-Authored-By: Claude Sonnet 5 <noreply@anthropic.com>
</commit_message>
<xml_diff>
--- a/docs/apresentacao/radar-tendencias-apresentacao.pptx
+++ b/docs/apresentacao/radar-tendencias-apresentacao.pptx
@@ -11323,14 +11323,37 @@
       </p:sp>
       <p:sp>
         <p:nvSpPr>
-          <p:cNvPr id="38" name="Text 31"/>
-          <p:cNvSpPr/>
-          <p:nvPr/>
-        </p:nvSpPr>
-        <p:spPr>
-          <a:xfrm>
-            <a:off x="640080" y="6473952"/>
-            <a:ext cx="7315200" cy="274320"/>
+          <p:cNvPr id="38" name="Shape 31"/>
+          <p:cNvSpPr/>
+          <p:nvPr/>
+        </p:nvSpPr>
+        <p:spPr>
+          <a:xfrm>
+            <a:off x="640080" y="5742432"/>
+            <a:ext cx="10911535" cy="0"/>
+          </a:xfrm>
+          <a:prstGeom prst="line">
+            <a:avLst/>
+          </a:prstGeom>
+          <a:noFill/>
+          <a:ln w="12700">
+            <a:solidFill>
+              <a:srgbClr val="26314A"/>
+            </a:solidFill>
+            <a:prstDash val="solid"/>
+          </a:ln>
+        </p:spPr>
+      </p:sp>
+      <p:sp>
+        <p:nvSpPr>
+          <p:cNvPr id="39" name="Text 32"/>
+          <p:cNvSpPr/>
+          <p:nvPr/>
+        </p:nvSpPr>
+        <p:spPr>
+          <a:xfrm>
+            <a:off x="640080" y="5852160"/>
+            <a:ext cx="10911535" cy="365760"/>
           </a:xfrm>
           <a:prstGeom prst="rect">
             <a:avLst/>
@@ -11342,11 +11365,11 @@
           <a:bodyPr wrap="square" lIns="0" tIns="0" rIns="0" bIns="0" rtlCol="0" anchor="ctr"/>
           <a:lstStyle/>
           <a:p>
-            <a:pPr indent="0" marL="0">
-              <a:buNone/>
-            </a:pPr>
-            <a:r>
-              <a:rPr lang="en-US" sz="900" spc="100" kern="0" dirty="0">
+            <a:pPr algn="ctr" indent="0" marL="0">
+              <a:buNone/>
+            </a:pPr>
+            <a:r>
+              <a:rPr lang="en-US" sz="1050" i="1" dirty="0">
                 <a:solidFill>
                   <a:srgbClr val="8CA0A8"/>
                 </a:solidFill>
@@ -11354,6 +11377,73 @@
                 <a:ea typeface="Calibri" pitchFamily="34" charset="-122"/>
                 <a:cs typeface="Calibri" pitchFamily="34" charset="-120"/>
               </a:rPr>
+              <a:t>Técnica de Shao et al., STORM — NAACL 2024, </a:t>
+            </a:r>
+            <a:pPr algn="ctr" indent="0" marL="0">
+              <a:buNone/>
+            </a:pPr>
+            <a:r>
+              <a:rPr lang="en-US" sz="1050" b="1" i="1" dirty="0">
+                <a:solidFill>
+                  <a:srgbClr val="00D9A3"/>
+                </a:solidFill>
+                <a:latin typeface="Calibri" pitchFamily="34" charset="0"/>
+                <a:ea typeface="Calibri" pitchFamily="34" charset="-122"/>
+                <a:cs typeface="Calibri" pitchFamily="34" charset="-120"/>
+              </a:rPr>
+              <a:t>Stanford OVAL</a:t>
+            </a:r>
+            <a:pPr algn="ctr" indent="0" marL="0">
+              <a:buNone/>
+            </a:pPr>
+            <a:r>
+              <a:rPr lang="en-US" sz="1050" i="1" dirty="0">
+                <a:solidFill>
+                  <a:srgbClr val="8CA0A8"/>
+                </a:solidFill>
+                <a:latin typeface="Calibri" pitchFamily="34" charset="0"/>
+                <a:ea typeface="Calibri" pitchFamily="34" charset="-122"/>
+                <a:cs typeface="Calibri" pitchFamily="34" charset="-120"/>
+              </a:rPr>
+              <a:t> (Open Virtual Assistant Lab). Adaptada, não importada — sem o framework `knowledge-storm`.</a:t>
+            </a:r>
+            <a:endParaRPr lang="en-US" sz="1050" dirty="0"/>
+          </a:p>
+        </p:txBody>
+      </p:sp>
+      <p:sp>
+        <p:nvSpPr>
+          <p:cNvPr id="40" name="Text 33"/>
+          <p:cNvSpPr/>
+          <p:nvPr/>
+        </p:nvSpPr>
+        <p:spPr>
+          <a:xfrm>
+            <a:off x="640080" y="6473952"/>
+            <a:ext cx="7315200" cy="274320"/>
+          </a:xfrm>
+          <a:prstGeom prst="rect">
+            <a:avLst/>
+          </a:prstGeom>
+          <a:noFill/>
+          <a:ln/>
+        </p:spPr>
+        <p:txBody>
+          <a:bodyPr wrap="square" lIns="0" tIns="0" rIns="0" bIns="0" rtlCol="0" anchor="ctr"/>
+          <a:lstStyle/>
+          <a:p>
+            <a:pPr indent="0" marL="0">
+              <a:buNone/>
+            </a:pPr>
+            <a:r>
+              <a:rPr lang="en-US" sz="900" spc="100" kern="0" dirty="0">
+                <a:solidFill>
+                  <a:srgbClr val="8CA0A8"/>
+                </a:solidFill>
+                <a:latin typeface="Calibri" pitchFamily="34" charset="0"/>
+                <a:ea typeface="Calibri" pitchFamily="34" charset="-122"/>
+                <a:cs typeface="Calibri" pitchFamily="34" charset="-120"/>
+              </a:rPr>
               <a:t>RADAR DE TENDÊNCIAS TECNOLÓGICAS  ·  SENAI DO FUTURO — IA</a:t>
             </a:r>
             <a:endParaRPr lang="en-US" sz="900" dirty="0"/>
@@ -11362,7 +11452,7 @@
       </p:sp>
       <p:sp>
         <p:nvSpPr>
-          <p:cNvPr id="39" name="Text 32"/>
+          <p:cNvPr id="41" name="Text 34"/>
           <p:cNvSpPr/>
           <p:nvPr/>
         </p:nvSpPr>

</xml_diff>